<commit_message>
Add PDF preview & GA4 scraping improvements
Switch slide previews from PNGs to a single PDF preview: add frontend iframe and HEAD checks for /reports/{id}/preview.pdf, implement render_pdf (LibreOffice-based) in slides.py, and add a new /reports/{id}/preview.pdf endpoint that serves cached or on-demand PDFs. Update report generation and apply-edits flows to produce PDF previews instead of individual PNG slides. Refactor GA4 scraping (generator.py / generator_2026.py) to capture richer previous-period metrics in a single browser session (countries, pages, snapshot, search metrics), add helpers for snapshot date handling and location assertions, and thread prev_ga4_metrics through recommendation generation. Add pdf2image to pyproject dependencies and update tests to use the new prev_ga4_metrics/search_metrics shape.
</commit_message>
<xml_diff>
--- a/test_slide7.pptx
+++ b/test_slide7.pptx
@@ -6338,7 +6338,7 @@
                 <a:ea typeface="Calibri"/>
                 <a:cs typeface="Calibri"/>
               </a:rPr>
-              <a:t>Clarify Key User Pathways</a:t>
+              <a:t>Optimize High-Traffic Information Pages for Conversion</a:t>
             </a:r>
           </a:p>
           <a:p>
@@ -6359,7 +6359,7 @@
                 <a:ea typeface="Calibri"/>
                 <a:cs typeface="Calibri"/>
               </a:rPr>
-              <a:t>Improve the specificity and actionability of call-to-action buttons across top performing pages to enhance user navigation and conversion efficiency.</a:t>
+              <a:t>To capitalize on the significant user interest evident from previous month's high traffic on informational pages, it is crucial to embed direct conversion paths guiding users from understanding to action.</a:t>
             </a:r>
           </a:p>
           <a:p>
@@ -6382,7 +6382,7 @@
                 <a:ea typeface="Calibri"/>
                 <a:cs typeface="Calibri"/>
               </a:rPr>
-              <a:t>Rephrase generic "GET STARTED" CTAs on the Econet Wireless Zimbabwe homepage, especially for the "EcoChat AI" section, to be more descriptive, such as "Start AI Conversation" or "Explore AI Features".</a:t>
+              <a:t>Integrate prominent and actionable "Participate Now" or "Purchase Bundles" calls to action on the "iJoy afta joy – Terms and Conditions" and "Smart4U Bundles Ts and Cs" pages.</a:t>
             </a:r>
           </a:p>
           <a:p>
@@ -6405,7 +6405,7 @@
                 <a:ea typeface="Calibri"/>
                 <a:cs typeface="Calibri"/>
               </a:rPr>
-              <a:t>Ensure that "GET STARTED" CTAs within the "I am living the difference" section on the homepage lead directly to relevant onboarding or service activation flows.</a:t>
+              <a:t>Ensure the "Recharge," "EcoCash," "Subscribe," and "Shop Online" elements on the "iJoy afta joy" page are clickable links that directly initiate these actions or lead to the specific transaction pages.</a:t>
             </a:r>
           </a:p>
           <a:p>
@@ -6428,7 +6428,7 @@
                 <a:ea typeface="Calibri"/>
                 <a:cs typeface="Calibri"/>
               </a:rPr>
-              <a:t>Review all "Shop Now" and "Buy Now" CTAs to confirm they provide direct, seamless links to product pages or the purchase process.</a:t>
+              <a:t>Display a clear, concise summary of how to engage with promotions or acquire bundles, with direct links, at the top of relevant terms and conditions pages.</a:t>
             </a:r>
           </a:p>
           <a:p>
@@ -6451,8 +6451,16 @@
                 <a:ea typeface="Calibri"/>
                 <a:cs typeface="Calibri"/>
               </a:rPr>
-              <a:t>Implement A/B testing for CTA button text and visual prominence to identify optimal conversion drivers on key landing pages.</a:t>
-            </a:r>
+              <a:t>Internal links from econet.co.zw will also help push more traffic and visibility to the shop.</a:t>
+            </a:r>
+            <a:endParaRPr lang="en-US" altLang="en-US" sz="900">
+              <a:solidFill>
+                <a:srgbClr val="000000"/>
+              </a:solidFill>
+              <a:latin typeface="Raleway" pitchFamily="2" charset="77"/>
+              <a:ea typeface="Calibri"/>
+              <a:cs typeface="Calibri"/>
+            </a:endParaRPr>
           </a:p>
           <a:p>
             <a:pPr algn="l" hangingPunct="0">
@@ -6472,7 +6480,7 @@
                 <a:ea typeface="Calibri"/>
                 <a:cs typeface="Calibri"/>
               </a:rPr>
-              <a:t>2. Elevate Digital Service Showcasing</a:t>
+              <a:t>2. Refine Homepage User Experience and Calls to Action</a:t>
             </a:r>
           </a:p>
           <a:p>
@@ -6493,7 +6501,7 @@
                 <a:ea typeface="Calibri"/>
                 <a:cs typeface="Calibri"/>
               </a:rPr>
-              <a:t>Maximize the visibility and user engagement with Econet's innovative digital offerings, specifically AI EcoChat and eSIM, to drive greater adoption.</a:t>
+              <a:t>To improve user engagement and guide visitors more efficiently towards key offerings, the homepage requires clearer calls to action and direct pathways to featured products.</a:t>
             </a:r>
           </a:p>
           <a:p>
@@ -6516,7 +6524,7 @@
                 <a:ea typeface="Calibri"/>
                 <a:cs typeface="Calibri"/>
               </a:rPr>
-              <a:t>Develop a dedicated promotional section for AI EcoChat on the Econet Wireless Zimbabwe homepage, highlighting its unique benefits and providing a clear entry point.</a:t>
+              <a:t>Add specific "Buy Now" buttons directly beneath each featured device within the "Connect in style" section of the Econet Wireless Zimbabwe homepage.</a:t>
             </a:r>
           </a:p>
           <a:p>
@@ -6539,7 +6547,7 @@
                 <a:ea typeface="Calibri"/>
                 <a:cs typeface="Calibri"/>
               </a:rPr>
-              <a:t>Integrate a prominent "Activate eSIM" button or link on the eSim page that guides users through the online or app-based activation process, complementing the existing QR code.</a:t>
+              <a:t>Replace generic "GET STARTED" CTAs with more descriptive, action-oriented labels such as "Explore Digital Services" or "Access EcoChat AI" to clarify the user's next step.</a:t>
             </a:r>
           </a:p>
           <a:p>
@@ -6562,8 +6570,16 @@
                 <a:ea typeface="Calibri"/>
                 <a:cs typeface="Calibri"/>
               </a:rPr>
-              <a:t>Explore creating interactive content, such as a short video tutorial, to simplify the understanding and activation of eSIM services.</a:t>
-            </a:r>
+              <a:t>This will help EWZ do more of the awareness and consideration work before users reach the estore.</a:t>
+            </a:r>
+            <a:endParaRPr lang="en-US" altLang="en-US" sz="900">
+              <a:solidFill>
+                <a:srgbClr val="000000"/>
+              </a:solidFill>
+              <a:latin typeface="Raleway" pitchFamily="2" charset="77"/>
+              <a:ea typeface="Calibri"/>
+              <a:cs typeface="Calibri"/>
+            </a:endParaRPr>
           </a:p>
           <a:p>
             <a:pPr algn="l" hangingPunct="0">
@@ -6583,7 +6599,7 @@
                 <a:ea typeface="Calibri"/>
                 <a:cs typeface="Calibri"/>
               </a:rPr>
-              <a:t>3. Improve Policy Page Readability</a:t>
+              <a:t>3. Streamline eSIM Acquisition Process Information</a:t>
             </a:r>
           </a:p>
           <a:p>
@@ -6604,7 +6620,7 @@
                 <a:ea typeface="Calibri"/>
                 <a:cs typeface="Calibri"/>
               </a:rPr>
-              <a:t>Enhance the structure and presentation of terms and conditions pages to make complex information more accessible and user-friendly.</a:t>
+              <a:t>To fully leverage the high user interest in eSIM technology, the eSIM page must provide clear guidance on how users can acquire an eSIM, not solely focus on activation.</a:t>
             </a:r>
           </a:p>
           <a:p>
@@ -6625,7 +6641,7 @@
                 <a:ea typeface="Calibri"/>
                 <a:cs typeface="Calibri"/>
               </a:rPr>
-              <a:t>Employ clearer headings, bullet points, and short paragraphs to break down dense text on pages such as "iJoy afta joy – Terms and Conditions" and "Smart4U Bundles Ts and Cs".</a:t>
+              <a:t>Introduce a distinct "How to Obtain Your eSIM" section on the "eSim" page, detailing the steps required for new eSIM users to get their profile.</a:t>
             </a:r>
           </a:p>
           <a:p>
@@ -6646,7 +6662,7 @@
                 <a:ea typeface="Calibri"/>
                 <a:cs typeface="Calibri"/>
               </a:rPr>
-              <a:t>Implement collapsible sections or accordions for detailed clauses, enabling users to easily navigate and focus on specific areas of interest.</a:t>
+              <a:t>Include a prominent call to action, such as "Request eSIM Online" or "Visit a Store for eSIM", with direct links to the relevant online portal or a store locator.</a:t>
             </a:r>
           </a:p>
         </p:txBody>

</xml_diff>